<commit_message>
Put the repository on the closing slide
A judge who believes the demo goes looking for the code, and the deck gave them
nowhere to go. It sits under the invitation to open the generated project, set
in mono so it reads as an address rather than as more prose.
</commit_message>
<xml_diff>
--- a/docs/HMI_Copilot_5min.pptx
+++ b/docs/HMI_Copilot_5min.pptx
@@ -7859,8 +7859,8 @@
         </p:nvSpPr>
         <p:spPr>
           <a:xfrm>
-            <a:off x="1005840" y="4892040"/>
-            <a:ext cx="10058400" cy="1280160"/>
+            <a:off x="1005840" y="4754880"/>
+            <a:ext cx="10058400" cy="914400"/>
           </a:xfrm>
           <a:prstGeom prst="rect">
             <a:avLst/>
@@ -7920,13 +7920,102 @@
       </p:sp>
       <p:sp>
         <p:nvSpPr>
-          <p:cNvPr id="8" name="TextBox 7"/>
+          <p:cNvPr id="8" name="Rectangle 7"/>
+          <p:cNvSpPr/>
+          <p:nvPr/>
+        </p:nvSpPr>
+        <p:spPr>
+          <a:xfrm>
+            <a:off x="1005840" y="5623560"/>
+            <a:ext cx="7863840" cy="566928"/>
+          </a:xfrm>
+          <a:prstGeom prst="rect">
+            <a:avLst/>
+          </a:prstGeom>
+          <a:solidFill>
+            <a:srgbClr val="1A222B"/>
+          </a:solidFill>
+          <a:ln>
+            <a:noFill/>
+          </a:ln>
+          <a:effectLst/>
+        </p:spPr>
+        <p:style>
+          <a:lnRef idx="1">
+            <a:schemeClr val="accent1"/>
+          </a:lnRef>
+          <a:fillRef idx="3">
+            <a:schemeClr val="accent1"/>
+          </a:fillRef>
+          <a:effectRef idx="2">
+            <a:schemeClr val="accent1"/>
+          </a:effectRef>
+          <a:fontRef idx="minor">
+            <a:schemeClr val="lt1"/>
+          </a:fontRef>
+        </p:style>
+        <p:txBody>
+          <a:bodyPr rtlCol="0" anchor="ctr"/>
+          <a:lstStyle/>
+          <a:p>
+            <a:pPr algn="ctr"/>
+          </a:p>
+        </p:txBody>
+      </p:sp>
+      <p:sp>
+        <p:nvSpPr>
+          <p:cNvPr id="9" name="TextBox 8"/>
           <p:cNvSpPr txBox="1"/>
           <p:nvPr/>
         </p:nvSpPr>
         <p:spPr>
           <a:xfrm>
-            <a:off x="1005840" y="6172200"/>
+            <a:off x="1234440" y="5715000"/>
+            <a:ext cx="7498079" cy="411480"/>
+          </a:xfrm>
+          <a:prstGeom prst="rect">
+            <a:avLst/>
+          </a:prstGeom>
+          <a:noFill/>
+        </p:spPr>
+        <p:txBody>
+          <a:bodyPr wrap="square" anchor="t" lIns="0" rIns="0" tIns="0" bIns="0">
+            <a:spAutoFit/>
+          </a:bodyPr>
+          <a:lstStyle/>
+          <a:p>
+            <a:pPr algn="l">
+              <a:lnSpc>
+                <a:spcPct val="125000"/>
+              </a:lnSpc>
+              <a:spcBef>
+                <a:spcPts val="0"/>
+              </a:spcBef>
+              <a:spcAft>
+                <a:spcPts val="600"/>
+              </a:spcAft>
+            </a:pPr>
+            <a:r>
+              <a:rPr sz="1500" b="1">
+                <a:solidFill>
+                  <a:srgbClr val="3DCD58"/>
+                </a:solidFill>
+                <a:latin typeface="Consolas"/>
+              </a:rPr>
+              <a:t>github.com/shauryaaojha/HMI_Copilot_EcoStruxure</a:t>
+            </a:r>
+          </a:p>
+        </p:txBody>
+      </p:sp>
+      <p:sp>
+        <p:nvSpPr>
+          <p:cNvPr id="10" name="TextBox 9"/>
+          <p:cNvSpPr txBox="1"/>
+          <p:nvPr/>
+        </p:nvSpPr>
+        <p:spPr>
+          <a:xfrm>
+            <a:off x="1005840" y="6382512"/>
             <a:ext cx="10058400" cy="365760"/>
           </a:xfrm>
           <a:prstGeom prst="rect">

</xml_diff>